<commit_message>
docs: remove repository link from closing slide
</commit_message>
<xml_diff>
--- a/documentation/CoviSpark_Presentation.pptx
+++ b/documentation/CoviSpark_Presentation.pptx
@@ -120,20 +120,20 @@
   <p:extLst>
     <p:ext uri="{521415D9-36F7-43E2-AB2F-B90AF26B5E84}">
       <p14:sectionLst xmlns:p14="http://schemas.microsoft.com/office/powerpoint/2010/main">
-        <p14:section name="Introduction" id="{eb79877b-3d1c-dbcf-0dc9-b2c7482ffae7}">
+        <p14:section name="Introduction" id="{33c8bccf-39aa-c73c-aad2-f460ee23edb8}">
           <p14:sldIdLst>
             <p14:sldId id="256"/>
             <p14:sldId id="257"/>
           </p14:sldIdLst>
         </p14:section>
-        <p14:section name="Architecture" id="{f0cd0352-3f38-0479-0e34-26efa1efab25}">
+        <p14:section name="Architecture" id="{cbd7be2d-095c-158c-9926-0233ba958774}">
           <p14:sldIdLst>
             <p14:sldId id="258"/>
             <p14:sldId id="259"/>
             <p14:sldId id="260"/>
           </p14:sldIdLst>
         </p14:section>
-        <p14:section name="Implementation" id="{0c79a3b4-0ab3-7eb1-f3de-dbb0a9fdfebc}">
+        <p14:section name="Implementation" id="{cbbb9471-b590-b0b3-de1a-d14027036fb6}">
           <p14:sldIdLst>
             <p14:sldId id="261"/>
             <p14:sldId id="262"/>
@@ -141,18 +141,18 @@
             <p14:sldId id="264"/>
           </p14:sldIdLst>
         </p14:section>
-        <p14:section name="Execution" id="{4c7f1b0c-4a68-3eb9-34ef-d564cb5cacc1}">
+        <p14:section name="Execution" id="{82a74f65-20b3-63f2-89f7-8dcf34100fc9}">
           <p14:sldIdLst>
             <p14:sldId id="265"/>
           </p14:sldIdLst>
         </p14:section>
-        <p14:section name="Results" id="{30c8e15b-791a-bda6-df6c-f0b4e2db5cb9}">
+        <p14:section name="Results" id="{2d56550b-0c26-9f96-18c9-bbe3d87b37d0}">
           <p14:sldIdLst>
             <p14:sldId id="266"/>
             <p14:sldId id="267"/>
           </p14:sldIdLst>
         </p14:section>
-        <p14:section name="Wrap-up" id="{3ea26672-089e-df21-9513-d73341771ded}">
+        <p14:section name="Wrap-up" id="{6f8f4d78-f14d-22d5-a918-3ed3b044e6ea}">
           <p14:sldIdLst>
             <p14:sldId id="268"/>
             <p14:sldId id="269"/>
@@ -8107,42 +8107,6 @@
       <p:sp>
         <p:nvSpPr>
           <p:cNvPr id="3" name="Text 1"/>
-          <p:cNvSpPr txBox="1"/>
-          <p:nvPr/>
-        </p:nvSpPr>
-        <p:spPr>
-          <a:xfrm>
-            <a:off x="731520" y="3429000"/>
-            <a:ext cx="8229600" cy="457200"/>
-          </a:xfrm>
-          <a:prstGeom prst="rect">
-            <a:avLst/>
-          </a:prstGeom>
-          <a:noFill/>
-          <a:ln/>
-        </p:spPr>
-        <p:txBody>
-          <a:bodyPr wrap="square" lIns="0" tIns="0" rIns="0" bIns="0" rtlCol="0" anchor="ctr"/>
-          <a:lstStyle/>
-          <a:p>
-            <a:pPr indent="0" marL="0">
-              <a:buNone/>
-            </a:pPr>
-            <a:r>
-              <a:rPr lang="en-US" sz="2000" dirty="0">
-                <a:solidFill>
-                  <a:srgbClr val="CADCFC"/>
-                </a:solidFill>
-              </a:rPr>
-              <a:t>github.com/gauriiiiiiiiiiii/CoviSpark</a:t>
-            </a:r>
-            <a:endParaRPr lang="en-US" sz="2000" dirty="0"/>
-          </a:p>
-        </p:txBody>
-      </p:sp>
-      <p:sp>
-        <p:nvSpPr>
-          <p:cNvPr id="4" name="Text 2"/>
           <p:cNvSpPr txBox="1"/>
           <p:nvPr/>
         </p:nvSpPr>

</xml_diff>

<commit_message>
docs: remove footer text from slides
</commit_message>
<xml_diff>
--- a/documentation/CoviSpark_Presentation.pptx
+++ b/documentation/CoviSpark_Presentation.pptx
@@ -120,20 +120,20 @@
   <p:extLst>
     <p:ext uri="{521415D9-36F7-43E2-AB2F-B90AF26B5E84}">
       <p14:sectionLst xmlns:p14="http://schemas.microsoft.com/office/powerpoint/2010/main">
-        <p14:section name="Introduction" id="{33c8bccf-39aa-c73c-aad2-f460ee23edb8}">
+        <p14:section name="Introduction" id="{681fa2a1-0a1c-0d5a-549b-e6bc49d9e4ac}">
           <p14:sldIdLst>
             <p14:sldId id="256"/>
             <p14:sldId id="257"/>
           </p14:sldIdLst>
         </p14:section>
-        <p14:section name="Architecture" id="{cbd7be2d-095c-158c-9926-0233ba958774}">
+        <p14:section name="Architecture" id="{a5fc62ce-5bf3-21d0-75ed-4f4aa9a00c5b}">
           <p14:sldIdLst>
             <p14:sldId id="258"/>
             <p14:sldId id="259"/>
             <p14:sldId id="260"/>
           </p14:sldIdLst>
         </p14:section>
-        <p14:section name="Implementation" id="{cbbb9471-b590-b0b3-de1a-d14027036fb6}">
+        <p14:section name="Implementation" id="{1a0a2399-adc8-afb9-cc75-76601d9bddea}">
           <p14:sldIdLst>
             <p14:sldId id="261"/>
             <p14:sldId id="262"/>
@@ -141,18 +141,18 @@
             <p14:sldId id="264"/>
           </p14:sldIdLst>
         </p14:section>
-        <p14:section name="Execution" id="{82a74f65-20b3-63f2-89f7-8dcf34100fc9}">
+        <p14:section name="Execution" id="{d0db850e-b186-2314-1ea4-d4a1e9dd85c1}">
           <p14:sldIdLst>
             <p14:sldId id="265"/>
           </p14:sldIdLst>
         </p14:section>
-        <p14:section name="Results" id="{2d56550b-0c26-9f96-18c9-bbe3d87b37d0}">
+        <p14:section name="Results" id="{8e96ef33-325f-3563-fbad-7cadd8c4ebac}">
           <p14:sldIdLst>
             <p14:sldId id="266"/>
             <p14:sldId id="267"/>
           </p14:sldIdLst>
         </p14:section>
-        <p14:section name="Wrap-up" id="{6f8f4d78-f14d-22d5-a918-3ed3b044e6ea}">
+        <p14:section name="Wrap-up" id="{27103fc9-44d3-97bd-557a-db4d5d67aee6}">
           <p14:sldIdLst>
             <p14:sldId id="268"/>
             <p14:sldId id="269"/>
@@ -4130,42 +4130,6 @@
               <a:buNone/>
             </a:pPr>
             <a:endParaRPr lang="en-US" sz="3200" dirty="0"/>
-          </a:p>
-        </p:txBody>
-      </p:sp>
-      <p:sp>
-        <p:nvSpPr>
-          <p:cNvPr id="3" name="Text 0"/>
-          <p:cNvSpPr/>
-          <p:nvPr/>
-        </p:nvSpPr>
-        <p:spPr>
-          <a:xfrm>
-            <a:off x="548640" y="6400800"/>
-            <a:ext cx="4572000" cy="274320"/>
-          </a:xfrm>
-          <a:prstGeom prst="rect">
-            <a:avLst/>
-          </a:prstGeom>
-          <a:noFill/>
-          <a:ln/>
-        </p:spPr>
-        <p:txBody>
-          <a:bodyPr wrap="square" lIns="0" tIns="0" rIns="0" bIns="0" rtlCol="0" anchor="ctr"/>
-          <a:lstStyle/>
-          <a:p>
-            <a:pPr indent="0" marL="0">
-              <a:buNone/>
-            </a:pPr>
-            <a:r>
-              <a:rPr lang="en-US" sz="1000" dirty="0">
-                <a:solidFill>
-                  <a:srgbClr val="6B7686"/>
-                </a:solidFill>
-              </a:rPr>
-              <a:t>CoviSpark · CSBB 422</a:t>
-            </a:r>
-            <a:endParaRPr lang="en-US" sz="1000" dirty="0"/>
           </a:p>
         </p:txBody>
       </p:sp>

</xml_diff>